<commit_message>
AutomaTivio: comentário de previdência automático, capa do HYD60 no e-mail e disclaimer maior nos Destaques
- Texto do HGD30/HYD60 montado sozinho: mercado do Institucional (comentarios.md) + frase com os números + complemento do mês (previdencia.md)
- Informativo: a letra da caixa de texto encolhe quando o texto do mês não cabe
- E-mail HYD60: capa publicada com o mês trocado por cima
- Destaques: disclaimer em 27 px, preenchendo a folha

Co-Authored-By: Claude Opus 5.5 <noreply@anthropic.com>
</commit_message>
<xml_diff>
--- a/AutomaTivio/saida/2026-09/informativos/Informativo - HGD30 - Setembro 2026.pptx
+++ b/AutomaTivio/saida/2026-09/informativos/Informativo - HGD30 - Setembro 2026.pptx
@@ -10610,7 +10610,7 @@
           <a:p>
             <a:pPr lvl="0" algn="just"/>
             <a:r>
-              <a:rPr lang="pt-BR" sz="1100" b="0">
+              <a:rPr lang="pt-BR" sz="1056" b="0">
                 <a:latin typeface="Versos" panose="020B0503020204030204" pitchFamily="34" charset="0"/>
               </a:rPr>
               <a:t>Em setembro, o mercado de crédito apresentou reabertura dos spreads e liquidez reduzida no mercado secundário. Os spreads médios dos títulos corporativos indexados ao CDI avançaram cerca de 5 bps, passando de CDI + 1,23% para CDI + 1,28% ao ano, interrompendo parcialmente o movimento de compressão observado nos últimos meses.</a:t>
@@ -10619,7 +10619,7 @@
           <a:p>
             <a:pPr lvl="0" algn="just"/>
             <a:r>
-              <a:rPr lang="pt-BR" sz="1100">
+              <a:rPr lang="pt-BR" sz="1056">
                 <a:latin typeface="Versos" panose="020B0503020204030204" pitchFamily="34" charset="0"/>
               </a:rPr>
               <a:t> </a:t>
@@ -10628,7 +10628,7 @@
           <a:p>
             <a:pPr lvl="0" algn="just"/>
             <a:r>
-              <a:rPr lang="pt-BR" sz="1100" b="0">
+              <a:rPr lang="pt-BR" sz="1056" b="0">
                 <a:latin typeface="Versos" panose="020B0503020204030204" pitchFamily="34" charset="0"/>
               </a:rPr>
               <a:t>No mercado secundário, a liquidez permaneceu limitada, especialmente em ativos corporativos, resultando em uma formação de preços mais seletiva. No mercado primário, as emissões bancárias seguiram registrando demanda consistente, embora com menor intensidade em comparação aos meses anteriores. Já o pipeline de emissões corporativas permaneceu restrito, mantendo a oferta de ativos em níveis reduzidos.</a:t>
@@ -10637,7 +10637,7 @@
           <a:p>
             <a:pPr lvl="0" algn="just"/>
             <a:r>
-              <a:rPr lang="pt-BR" sz="1100">
+              <a:rPr lang="pt-BR" sz="1056">
                 <a:latin typeface="Versos" panose="020B0503020204030204" pitchFamily="34" charset="0"/>
               </a:rPr>
               <a:t> </a:t>
@@ -10646,7 +10646,7 @@
           <a:p>
             <a:pPr lvl="0" algn="just"/>
             <a:r>
-              <a:rPr lang="pt-BR" sz="1100" b="0">
+              <a:rPr lang="pt-BR" sz="1056" b="0">
                 <a:latin typeface="Versos" panose="020B0503020204030204" pitchFamily="34" charset="0"/>
               </a:rPr>
               <a:t>Em relação aos fluxos, os fundos com alocação mínima de 15% em crédito e ao menos 1% em debêntures registraram resgates líquidos próximos de R$ 10 bilhões no período, movimento que contribuiu para a reabertura dos spreads e para uma piora da dinâmica técnica da classe.</a:t>
@@ -10655,7 +10655,7 @@
           <a:p>
             <a:pPr lvl="0" algn="just"/>
             <a:r>
-              <a:rPr lang="pt-BR" sz="1100">
+              <a:rPr lang="pt-BR" sz="1056">
                 <a:latin typeface="Versos" panose="020B0503020204030204" pitchFamily="34" charset="0"/>
               </a:rPr>
               <a:t> </a:t>
@@ -10664,7 +10664,7 @@
           <a:p>
             <a:pPr lvl="0" algn="just"/>
             <a:r>
-              <a:rPr lang="pt-BR" sz="1100" b="0">
+              <a:rPr lang="pt-BR" sz="1056" b="0">
                 <a:latin typeface="Versos" panose="020B0503020204030204" pitchFamily="34" charset="0"/>
               </a:rPr>
               <a:t>Apesar desse cenário, os fundamentos corporativos permanecem resilientes e os níveis de inadimplência seguem controlados. Sob a ótica da gestão, mantemos uma postura disciplinada e seletiva na alocação dos recursos, buscando capturar oportunidades geradas pela recente abertura dos spreads sem abrir mão da qualidade de crédito das carteiras.</a:t>
@@ -10673,7 +10673,7 @@
           <a:p>
             <a:pPr lvl="0" algn="just"/>
             <a:r>
-              <a:rPr lang="pt-BR" sz="1100">
+              <a:rPr lang="pt-BR" sz="1056">
                 <a:latin typeface="Versos" panose="020B0503020204030204" pitchFamily="34" charset="0"/>
               </a:rPr>
               <a:t> </a:t>
@@ -10682,13 +10682,13 @@
           <a:p>
             <a:pPr lvl="0" algn="just"/>
             <a:r>
-              <a:rPr lang="pt-BR" sz="1100" b="0">
+              <a:rPr lang="pt-BR" sz="1056" b="0">
                 <a:latin typeface="Versos" panose="020B0503020204030204" pitchFamily="34" charset="0"/>
               </a:rPr>
               <a:t>Nesse cenário, o </a:t>
             </a:r>
             <a:r>
-              <a:rPr lang="pt-BR" sz="1100" b="1">
+              <a:rPr lang="pt-BR" sz="1056" b="1">
                 <a:latin typeface="Versos" panose="020B0503020204030204" pitchFamily="34" charset="0"/>
               </a:rPr>
               <a:t>Tivio HGD30 apresentou rentabilidade de 1,09% no mês (100% do CDI), acumulando 14,66% (101% do CDI) em 12 meses.</a:t>
@@ -10697,7 +10697,7 @@
           <a:p>
             <a:pPr lvl="0" algn="just"/>
             <a:r>
-              <a:rPr lang="pt-BR" sz="1100">
+              <a:rPr lang="pt-BR" sz="1056">
                 <a:latin typeface="Versos" panose="020B0503020204030204" pitchFamily="34" charset="0"/>
               </a:rPr>
               <a:t> </a:t>
@@ -10706,7 +10706,7 @@
           <a:p>
             <a:pPr lvl="0" algn="just"/>
             <a:r>
-              <a:rPr lang="pt-BR" sz="1100" b="0">
+              <a:rPr lang="pt-BR" sz="1056" b="0">
                 <a:latin typeface="Versos" panose="020B0503020204030204" pitchFamily="34" charset="0"/>
               </a:rPr>
               <a:t>Na atribuição de performance, a carteira de títulos bancários foi a principal responsável pelo resultado do período, contribuindo com aproximadamente 3 bps de alfa, com destaque para a parcela de LFs perpétuas.</a:t>
@@ -10715,7 +10715,7 @@
           <a:p>
             <a:pPr lvl="0" algn="just"/>
             <a:r>
-              <a:rPr lang="pt-BR" sz="1100">
+              <a:rPr lang="pt-BR" sz="1056">
                 <a:latin typeface="Versos" panose="020B0503020204030204" pitchFamily="34" charset="0"/>
               </a:rPr>
               <a:t> </a:t>
@@ -10724,7 +10724,7 @@
           <a:p>
             <a:pPr lvl="0" algn="just"/>
             <a:r>
-              <a:rPr lang="pt-BR" sz="1100" b="0">
+              <a:rPr lang="pt-BR" sz="1056" b="0">
                 <a:latin typeface="Versos" panose="020B0503020204030204" pitchFamily="34" charset="0"/>
               </a:rPr>
               <a:t>Por outro lado, a carteira de debêntures foi a principal detratora de performance, com impacto negativo de cerca de 1,3 bps de alfa. Dentro da classe, os destaques positivos foram os papéis de Tupy e Randon, que conjuntamente adicionaram 2,3 bps de rentabilidade acima do CDI. Em contrapartida, Hapvida e Sendas foram os principais detratores do mês, com contribuição combinada de aproximadamente 2,5 bps abaixo do CDI.</a:t>

</xml_diff>